<commit_message>
Update Week 2 PPTX slide decks to reflect correct Personas
</commit_message>
<xml_diff>
--- a/docs/Week2_Synthetic_Data_Deck.pptx
+++ b/docs/Week2_Synthetic_Data_Deck.pptx
@@ -8703,101 +8703,47 @@
           </a:bodyPr>
           <a:lstStyle/>
           <a:p>
-            <a:pPr/>
-            <a:r>
-              <a:rPr sz="1300">
-                <a:solidFill>
-                  <a:srgbClr val="C8E0F4"/>
-                </a:solidFill>
-              </a:rPr>
+            <a:r>
               <a:t>• Airport Business  →  ITE ≈ +0.5</a:t>
             </a:r>
           </a:p>
           <a:p>
-            <a:pPr lvl="1"/>
-            <a:r>
-              <a:rPr sz="1300">
-                <a:solidFill>
-                  <a:srgbClr val="C8E0F4"/>
-                </a:solidFill>
-              </a:rPr>
+            <a:r>
               <a:t>  - Khách ra sân bay bắt buộc phải đi</a:t>
             </a:r>
           </a:p>
           <a:p>
-            <a:pPr lvl="1"/>
-            <a:r>
-              <a:rPr sz="1300">
-                <a:solidFill>
-                  <a:srgbClr val="FF4D6D"/>
-                </a:solidFill>
-              </a:rPr>
+            <a:r>
               <a:t>  - Voucher là tiền vứt qua cửa sổ</a:t>
             </a:r>
           </a:p>
           <a:p>
-            <a:pPr/>
-            <a:r>
-              <a:rPr sz="1300">
-                <a:solidFill>
-                  <a:srgbClr val="C8E0F4"/>
-                </a:solidFill>
-              </a:rPr>
-              <a:t>• Urban Cash (Rush Hour)  →  ITE ≈ +1.0</a:t>
-            </a:r>
-          </a:p>
-          <a:p>
-            <a:pPr lvl="1"/>
-            <a:r>
-              <a:rPr sz="1300">
-                <a:solidFill>
-                  <a:srgbClr val="C8E0F4"/>
-                </a:solidFill>
-              </a:rPr>
+            <a:r>
+              <a:t>• Urban Regulars (Rush Hour)  →  ITE ≈ +1.0</a:t>
+            </a:r>
+          </a:p>
+          <a:p>
+            <a:r>
               <a:t>  - Đi làm hàng ngày, dù không có mã vẫn đi</a:t>
             </a:r>
           </a:p>
           <a:p>
-            <a:pPr lvl="1"/>
-            <a:r>
-              <a:rPr sz="1300">
-                <a:solidFill>
-                  <a:srgbClr val="FF4D6D"/>
-                </a:solidFill>
-              </a:rPr>
+            <a:r>
               <a:t>  - Cannibalization Effect cực cao</a:t>
             </a:r>
           </a:p>
           <a:p>
-            <a:pPr/>
-            <a:r>
-              <a:rPr sz="1300">
-                <a:solidFill>
-                  <a:srgbClr val="C8E0F4"/>
-                </a:solidFill>
-              </a:rPr>
+            <a:r>
               <a:t>• Rain Riders  →  ITE ≈ +1.5</a:t>
             </a:r>
           </a:p>
           <a:p>
-            <a:pPr lvl="1"/>
-            <a:r>
-              <a:rPr sz="1300">
-                <a:solidFill>
-                  <a:srgbClr val="C8E0F4"/>
-                </a:solidFill>
-              </a:rPr>
+            <a:r>
               <a:t>  - Nhu cầu phát sinh từ thời tiết, không phải giá</a:t>
             </a:r>
           </a:p>
           <a:p>
-            <a:pPr lvl="1"/>
-            <a:r>
-              <a:rPr sz="1300">
-                <a:solidFill>
-                  <a:srgbClr val="FF4D6D"/>
-                </a:solidFill>
-              </a:rPr>
+            <a:r>
               <a:t>  - Tặng Voucher không kích thêm được chuyến</a:t>
             </a:r>
           </a:p>
@@ -8902,79 +8848,37 @@
           </a:bodyPr>
           <a:lstStyle/>
           <a:p>
-            <a:pPr/>
-            <a:r>
-              <a:rPr sz="1300">
-                <a:solidFill>
-                  <a:srgbClr val="C8E0F4"/>
-                </a:solidFill>
-              </a:rPr>
-              <a:t>• Suburban Occasionals  →  ITE ≈ +3.0</a:t>
-            </a:r>
-          </a:p>
-          <a:p>
-            <a:pPr lvl="1"/>
-            <a:r>
-              <a:rPr sz="1300">
-                <a:solidFill>
-                  <a:srgbClr val="C8E0F4"/>
-                </a:solidFill>
-              </a:rPr>
+            <a:r>
+              <a:t>• Suburban Card  →  ITE ≈ +3.0</a:t>
+            </a:r>
+          </a:p>
+          <a:p>
+            <a:r>
               <a:t>  - Khách ngoại ô, ít đi xe vì không có mã</a:t>
             </a:r>
           </a:p>
           <a:p>
-            <a:pPr lvl="1"/>
-            <a:r>
-              <a:rPr sz="1300">
-                <a:solidFill>
-                  <a:srgbClr val="06D6A0"/>
-                </a:solidFill>
-              </a:rPr>
+            <a:r>
               <a:t>  - Voucher thực sự kéo họ ra đường</a:t>
             </a:r>
           </a:p>
           <a:p>
-            <a:pPr/>
-            <a:r>
-              <a:rPr sz="1300">
-                <a:solidFill>
-                  <a:srgbClr val="C8E0F4"/>
-                </a:solidFill>
-              </a:rPr>
-              <a:t>• Urban Credit Card  →  ITE ≈ +2.5</a:t>
-            </a:r>
-          </a:p>
-          <a:p>
-            <a:pPr lvl="1"/>
-            <a:r>
-              <a:rPr sz="1300">
-                <a:solidFill>
-                  <a:srgbClr val="C8E0F4"/>
-                </a:solidFill>
-              </a:rPr>
+            <a:r>
+              <a:t>• Suburban Cash  →  ITE ≈ +2.5</a:t>
+            </a:r>
+          </a:p>
+          <a:p>
+            <a:r>
               <a:t>  - Khách đi chơi cuối tuần, nhạy cảm với giá</a:t>
             </a:r>
           </a:p>
           <a:p>
-            <a:pPr lvl="1"/>
-            <a:r>
-              <a:rPr sz="1300">
-                <a:solidFill>
-                  <a:srgbClr val="06D6A0"/>
-                </a:solidFill>
-              </a:rPr>
+            <a:r>
               <a:t>  - ROI dương trong kết quả A/B Test</a:t>
             </a:r>
           </a:p>
           <a:p>
-            <a:pPr/>
-            <a:r>
-              <a:rPr sz="1300">
-                <a:solidFill>
-                  <a:srgbClr val="00B4D8"/>
-                </a:solidFill>
-              </a:rPr>
+            <a:r>
               <a:t>• → Voucher đúng là kích thích hành vi của nhóm này</a:t>
             </a:r>
           </a:p>
@@ -9276,14 +9180,8 @@
           </a:bodyPr>
           <a:lstStyle/>
           <a:p>
-            <a:pPr algn="ctr"/>
-            <a:r>
-              <a:rPr sz="1000" b="0">
-                <a:solidFill>
-                  <a:srgbClr val="C8E0F4"/>
-                </a:solidFill>
-              </a:rPr>
-              <a:t>Urban Cash (đi làm)</a:t>
+            <a:r>
+              <a:t>Urban Regulars (đi làm)</a:t>
             </a:r>
           </a:p>
         </p:txBody>
@@ -9430,14 +9328,8 @@
           </a:bodyPr>
           <a:lstStyle/>
           <a:p>
-            <a:pPr algn="ctr"/>
-            <a:r>
-              <a:rPr sz="1000" b="0">
-                <a:solidFill>
-                  <a:srgbClr val="C8E0F4"/>
-                </a:solidFill>
-              </a:rPr>
-              <a:t>Urban Credit Card (nhạy cảm giá)</a:t>
+            <a:r>
+              <a:t>Suburban Cash (nhạy cảm giá)</a:t>
             </a:r>
           </a:p>
         </p:txBody>
@@ -9584,14 +9476,8 @@
           </a:bodyPr>
           <a:lstStyle/>
           <a:p>
-            <a:pPr algn="ctr"/>
-            <a:r>
-              <a:rPr sz="1000" b="0">
-                <a:solidFill>
-                  <a:srgbClr val="C8E0F4"/>
-                </a:solidFill>
-              </a:rPr>
-              <a:t>Suburban Occasionals (nhạy nhất)</a:t>
+            <a:r>
+              <a:t>Suburban Card (nhạy nhất)</a:t>
             </a:r>
           </a:p>
         </p:txBody>

</xml_diff>

<commit_message>
Update ITE formula on Slide 5 of Week 2 PPTX to match final pipeline
</commit_message>
<xml_diff>
--- a/docs/Week2_Synthetic_Data_Deck.pptx
+++ b/docs/Week2_Synthetic_Data_Deck.pptx
@@ -8592,14 +8592,8 @@
           </a:bodyPr>
           <a:lstStyle/>
           <a:p>
-            <a:pPr algn="ctr"/>
-            <a:r>
-              <a:rPr sz="1400" b="1">
-                <a:solidFill>
-                  <a:srgbClr val="FF9F1C"/>
-                </a:solidFill>
-              </a:rPr>
-              <a:t>ITE = 2.0 (Base)  −  1.5 × is_airport  −  1.0 × is_rush_hour  +  1.0 × (1 − is_urban)  +  0.5 × is_rain_rider</a:t>
+            <a:r>
+              <a:t>ITE = 2.0 (Base) + 2.0 × SuburbanLeisure + 0.5 × RainAge − 1.5 × is_airport − 1.0 × is_rush_hour − 0.5 × is_cash + RecencyBoost</a:t>
             </a:r>
           </a:p>
         </p:txBody>

</xml_diff>

<commit_message>
Fix residual ITE values in PPTX bullet points to match new formula calculations
</commit_message>
<xml_diff>
--- a/docs/Week2_Synthetic_Data_Deck.pptx
+++ b/docs/Week2_Synthetic_Data_Deck.pptx
@@ -8698,7 +8698,7 @@
           <a:lstStyle/>
           <a:p>
             <a:r>
-              <a:t>• Airport Business  →  ITE ≈ +0.5</a:t>
+              <a:t>• Airport Business  →  ITE ≈ +0.0</a:t>
             </a:r>
           </a:p>
           <a:p>
@@ -8713,7 +8713,7 @@
           </a:p>
           <a:p>
             <a:r>
-              <a:t>• Urban Regulars (Rush Hour)  →  ITE ≈ +1.0</a:t>
+              <a:t>• Urban Regulars (Rush Hour)  →  ITE ≈ +0.7</a:t>
             </a:r>
           </a:p>
           <a:p>
@@ -8728,7 +8728,7 @@
           </a:p>
           <a:p>
             <a:r>
-              <a:t>• Rain Riders  →  ITE ≈ +1.5</a:t>
+              <a:t>• Rain Riders  →  ITE ≈ +1.9</a:t>
             </a:r>
           </a:p>
           <a:p>
@@ -8843,7 +8843,7 @@
           <a:lstStyle/>
           <a:p>
             <a:r>
-              <a:t>• Suburban Card  →  ITE ≈ +3.0</a:t>
+              <a:t>• Suburban Card  →  ITE ≈ +2.3</a:t>
             </a:r>
           </a:p>
           <a:p>
@@ -8858,7 +8858,7 @@
           </a:p>
           <a:p>
             <a:r>
-              <a:t>• Suburban Cash  →  ITE ≈ +2.5</a:t>
+              <a:t>• Suburban Cash  →  ITE ≈ +1.4</a:t>
             </a:r>
           </a:p>
           <a:p>

</xml_diff>

<commit_message>
Fix font colors that turned black after replacing text in PPTX
</commit_message>
<xml_diff>
--- a/docs/Week2_Synthetic_Data_Deck.pptx
+++ b/docs/Week2_Synthetic_Data_Deck.pptx
@@ -8593,6 +8593,11 @@
           <a:lstStyle/>
           <a:p>
             <a:r>
+              <a:rPr>
+                <a:solidFill>
+                  <a:srgbClr val="FFFFFF"/>
+                </a:solidFill>
+              </a:rPr>
               <a:t>ITE = 1.5 (Base) + 1.2 × UrbanLeisure + 0.8 × SuburbanLeisure + 0.4 × RainAge − 1.5 × is_airport − 0.8 × is_rush_hour − 0.9 × is_cash + RecencyBoost</a:t>
             </a:r>
           </a:p>
@@ -8698,46 +8703,91 @@
           <a:lstStyle/>
           <a:p>
             <a:r>
+              <a:rPr>
+                <a:solidFill>
+                  <a:srgbClr val="FFFFFF"/>
+                </a:solidFill>
+              </a:rPr>
               <a:t>• Airport Business  →  ITE ≈ +0.0</a:t>
             </a:r>
           </a:p>
           <a:p>
             <a:r>
+              <a:rPr>
+                <a:solidFill>
+                  <a:srgbClr val="FFFFFF"/>
+                </a:solidFill>
+              </a:rPr>
               <a:t>  - Khách ra sân bay bắt buộc phải đi</a:t>
             </a:r>
           </a:p>
           <a:p>
             <a:r>
+              <a:rPr>
+                <a:solidFill>
+                  <a:srgbClr val="FFFFFF"/>
+                </a:solidFill>
+              </a:rPr>
               <a:t>  - Voucher là tiền vứt qua cửa sổ</a:t>
             </a:r>
           </a:p>
           <a:p>
             <a:r>
+              <a:rPr>
+                <a:solidFill>
+                  <a:srgbClr val="FFFFFF"/>
+                </a:solidFill>
+              </a:rPr>
               <a:t>• Urban Regulars (Rush Hour)  →  ITE ≈ +0.7</a:t>
             </a:r>
           </a:p>
           <a:p>
             <a:r>
+              <a:rPr>
+                <a:solidFill>
+                  <a:srgbClr val="FFFFFF"/>
+                </a:solidFill>
+              </a:rPr>
               <a:t>  - Đi làm hàng ngày, dù không có mã vẫn đi</a:t>
             </a:r>
           </a:p>
           <a:p>
             <a:r>
+              <a:rPr>
+                <a:solidFill>
+                  <a:srgbClr val="FFFFFF"/>
+                </a:solidFill>
+              </a:rPr>
               <a:t>  - Cannibalization Effect cực cao</a:t>
             </a:r>
           </a:p>
           <a:p>
             <a:r>
+              <a:rPr>
+                <a:solidFill>
+                  <a:srgbClr val="FFFFFF"/>
+                </a:solidFill>
+              </a:rPr>
               <a:t>• Rain Riders  →  ITE ≈ +1.9</a:t>
             </a:r>
           </a:p>
           <a:p>
             <a:r>
+              <a:rPr>
+                <a:solidFill>
+                  <a:srgbClr val="FFFFFF"/>
+                </a:solidFill>
+              </a:rPr>
               <a:t>  - Nhu cầu phát sinh từ thời tiết, không phải giá</a:t>
             </a:r>
           </a:p>
           <a:p>
             <a:r>
+              <a:rPr>
+                <a:solidFill>
+                  <a:srgbClr val="FFFFFF"/>
+                </a:solidFill>
+              </a:rPr>
               <a:t>  - Tặng Voucher không kích thêm được chuyến</a:t>
             </a:r>
           </a:p>
@@ -8843,36 +8893,71 @@
           <a:lstStyle/>
           <a:p>
             <a:r>
+              <a:rPr>
+                <a:solidFill>
+                  <a:srgbClr val="FFFFFF"/>
+                </a:solidFill>
+              </a:rPr>
               <a:t>• Suburban Card  →  ITE ≈ +2.3</a:t>
             </a:r>
           </a:p>
           <a:p>
             <a:r>
+              <a:rPr>
+                <a:solidFill>
+                  <a:srgbClr val="FFFFFF"/>
+                </a:solidFill>
+              </a:rPr>
               <a:t>  - Khách ngoại ô, ít đi xe vì không có mã</a:t>
             </a:r>
           </a:p>
           <a:p>
             <a:r>
+              <a:rPr>
+                <a:solidFill>
+                  <a:srgbClr val="FFFFFF"/>
+                </a:solidFill>
+              </a:rPr>
               <a:t>  - Voucher thực sự kéo họ ra đường</a:t>
             </a:r>
           </a:p>
           <a:p>
             <a:r>
+              <a:rPr>
+                <a:solidFill>
+                  <a:srgbClr val="FFFFFF"/>
+                </a:solidFill>
+              </a:rPr>
               <a:t>• Suburban Cash  →  ITE ≈ +1.4</a:t>
             </a:r>
           </a:p>
           <a:p>
             <a:r>
+              <a:rPr>
+                <a:solidFill>
+                  <a:srgbClr val="FFFFFF"/>
+                </a:solidFill>
+              </a:rPr>
               <a:t>  - Khách đi chơi cuối tuần, nhạy cảm với giá</a:t>
             </a:r>
           </a:p>
           <a:p>
             <a:r>
+              <a:rPr>
+                <a:solidFill>
+                  <a:srgbClr val="FFFFFF"/>
+                </a:solidFill>
+              </a:rPr>
               <a:t>  - ROI dương trong kết quả A/B Test</a:t>
             </a:r>
           </a:p>
           <a:p>
             <a:r>
+              <a:rPr>
+                <a:solidFill>
+                  <a:srgbClr val="FFFFFF"/>
+                </a:solidFill>
+              </a:rPr>
               <a:t>• → Voucher đúng là kích thích hành vi của nhóm này</a:t>
             </a:r>
           </a:p>
@@ -8986,14 +9071,13 @@
           </a:bodyPr>
           <a:lstStyle/>
           <a:p>
-            <a:pPr algn="ctr"/>
-            <a:r>
-              <a:rPr sz="2000" b="1">
-                <a:solidFill>
-                  <a:srgbClr val="FF9F1C"/>
-                </a:solidFill>
-              </a:rPr>
-              <a:t>ITE = +0.5</a:t>
+            <a:r>
+              <a:rPr>
+                <a:solidFill>
+                  <a:srgbClr val="FFFFFF"/>
+                </a:solidFill>
+              </a:rPr>
+              <a:t>ITE ≈ 0.0</a:t>
             </a:r>
           </a:p>
         </p:txBody>
@@ -9140,14 +9224,13 @@
           </a:bodyPr>
           <a:lstStyle/>
           <a:p>
-            <a:pPr algn="ctr"/>
-            <a:r>
-              <a:rPr sz="2000" b="1">
-                <a:solidFill>
-                  <a:srgbClr val="FF9F1C"/>
-                </a:solidFill>
-              </a:rPr>
-              <a:t>ITE = +1.0</a:t>
+            <a:r>
+              <a:rPr>
+                <a:solidFill>
+                  <a:srgbClr val="FFFFFF"/>
+                </a:solidFill>
+              </a:rPr>
+              <a:t>ITE ≈ +0.7</a:t>
             </a:r>
           </a:p>
         </p:txBody>
@@ -9288,14 +9371,13 @@
           </a:bodyPr>
           <a:lstStyle/>
           <a:p>
-            <a:pPr algn="ctr"/>
-            <a:r>
-              <a:rPr sz="2000" b="1">
-                <a:solidFill>
-                  <a:srgbClr val="FF9F1C"/>
-                </a:solidFill>
-              </a:rPr>
-              <a:t>ITE = +2.5</a:t>
+            <a:r>
+              <a:rPr>
+                <a:solidFill>
+                  <a:srgbClr val="FFFFFF"/>
+                </a:solidFill>
+              </a:rPr>
+              <a:t>ITE ≈ +1.4</a:t>
             </a:r>
           </a:p>
         </p:txBody>
@@ -9436,14 +9518,13 @@
           </a:bodyPr>
           <a:lstStyle/>
           <a:p>
-            <a:pPr algn="ctr"/>
-            <a:r>
-              <a:rPr sz="2000" b="1">
-                <a:solidFill>
-                  <a:srgbClr val="FF9F1C"/>
-                </a:solidFill>
-              </a:rPr>
-              <a:t>ITE = +3.0</a:t>
+            <a:r>
+              <a:rPr>
+                <a:solidFill>
+                  <a:srgbClr val="FFFFFF"/>
+                </a:solidFill>
+              </a:rPr>
+              <a:t>ITE ≈ +2.3</a:t>
             </a:r>
           </a:p>
         </p:txBody>

</xml_diff>

<commit_message>
Fix text color of persona names at the bottom of Week 2 PPTX slide
</commit_message>
<xml_diff>
--- a/docs/Week2_Synthetic_Data_Deck.pptx
+++ b/docs/Week2_Synthetic_Data_Deck.pptx
@@ -7359,7 +7359,7 @@
             <a:r>
               <a:rPr sz="1300">
                 <a:solidFill>
-                  <a:srgbClr val="C8E0F4"/>
+                  <a:srgbClr val="FFFFFF"/>
                 </a:solidFill>
               </a:rPr>
               <a:t>• Outcome ↑: Khách vẫn PHẢI đi làm dù không có mã giảm</a:t>
@@ -7877,7 +7877,7 @@
             <a:r>
               <a:rPr sz="1000" b="0">
                 <a:solidFill>
-                  <a:srgbClr val="C8E0F4"/>
+                  <a:srgbClr val="FFFFFF"/>
                 </a:solidFill>
               </a:rPr>
               <a:t>Tỷ lệ Airport Business</a:t>

</xml_diff>

<commit_message>
Fix text color of persona names on Slide 4 of Week 2 PPTX
</commit_message>
<xml_diff>
--- a/docs/Week2_Synthetic_Data_Deck.pptx
+++ b/docs/Week2_Synthetic_Data_Deck.pptx
@@ -9108,7 +9108,7 @@
             <a:r>
               <a:rPr sz="1000" b="0">
                 <a:solidFill>
-                  <a:srgbClr val="C8E0F4"/>
+                  <a:srgbClr val="FFFFFF"/>
                 </a:solidFill>
               </a:rPr>
               <a:t>Airport Business (kháng cao nhất)</a:t>
@@ -9258,6 +9258,11 @@
           <a:lstStyle/>
           <a:p>
             <a:r>
+              <a:rPr>
+                <a:solidFill>
+                  <a:srgbClr val="FFFFFF"/>
+                </a:solidFill>
+              </a:rPr>
               <a:t>Urban Regulars (đi làm)</a:t>
             </a:r>
           </a:p>
@@ -9405,6 +9410,11 @@
           <a:lstStyle/>
           <a:p>
             <a:r>
+              <a:rPr>
+                <a:solidFill>
+                  <a:srgbClr val="FFFFFF"/>
+                </a:solidFill>
+              </a:rPr>
               <a:t>Suburban Cash (nhạy cảm giá)</a:t>
             </a:r>
           </a:p>
@@ -9552,6 +9562,11 @@
           <a:lstStyle/>
           <a:p>
             <a:r>
+              <a:rPr>
+                <a:solidFill>
+                  <a:srgbClr val="FFFFFF"/>
+                </a:solidFill>
+              </a:rPr>
               <a:t>Suburban Card (nhạy nhất)</a:t>
             </a:r>
           </a:p>

</xml_diff>